<commit_message>
Use selective-expansion results in midterm deck
Slide 2 now reports the development-set combination run from
feat-retrieval-optimizations: hybrid search and disagreement-gated LameR
expansion (nDCG@5 0.855 at 592 ms vs 0.825 at 1,320 ms when always
expanding). Slide 1 marks hybrid retrieval and the evidence check as built.

Co-Authored-By: Claude Opus 5.5 <noreply@anthropic.com>
</commit_message>
<xml_diff>
--- a/docs/presentation/Team13-Midterm-v2.pptx
+++ b/docs/presentation/Team13-Midterm-v2.pptx
@@ -106,331 +106,6 @@
     </a:lvl9pPr>
   </p:defaultTextStyle>
 </p:presentation>
-</file>
-
-<file path=ppt/charts/chart1.xml><?xml version="1.0" encoding="utf-8"?>
-<c:chartSpace xmlns:c="http://schemas.openxmlformats.org/drawingml/2006/chart" xmlns:a="http://schemas.openxmlformats.org/drawingml/2006/main" xmlns:r="http://schemas.openxmlformats.org/officeDocument/2006/relationships">
-  <c:date1904 val="0"/>
-  <c:roundedCorners val="1"/>
-  <c:chart>
-    <c:title>
-      <c:tx>
-        <c:rich>
-          <a:bodyPr/>
-          <a:lstStyle/>
-          <a:p>
-            <a:pPr>
-              <a:defRPr sz="1200" b="0" i="0" u="none" strike="noStrike">
-                <a:solidFill>
-                  <a:srgbClr val="5B6770"/>
-                </a:solidFill>
-                <a:latin typeface="Calibri"/>
-              </a:defRPr>
-            </a:pPr>
-            <a:r>
-              <a:rPr sz="1200" b="0" i="0" u="none" strike="noStrike">
-                <a:solidFill>
-                  <a:srgbClr val="5B6770"/>
-                </a:solidFill>
-                <a:latin typeface="Calibri"/>
-              </a:rPr>
-              <a:t>Gold document in top 5 (MRR 0.67)</a:t>
-            </a:r>
-          </a:p>
-        </c:rich>
-      </c:tx>
-      <c:layout/>
-      <c:overlay val="0"/>
-    </c:title>
-    <c:autoTitleDeleted val="0"/>
-    <c:plotArea>
-      <c:layout/>
-      <c:barChart>
-        <c:barDir val="bar"/>
-        <c:grouping val="clustered"/>
-        <c:varyColors val="0"/>
-        <c:ser>
-          <c:idx val="0"/>
-          <c:order val="0"/>
-          <c:tx>
-            <c:strRef>
-              <c:f>Sheet1!$B$1</c:f>
-              <c:strCache>
-                <c:ptCount val="1"/>
-                <c:pt idx="0">
-                  <c:v>Hit@5</c:v>
-                </c:pt>
-              </c:strCache>
-            </c:strRef>
-          </c:tx>
-          <c:spPr>
-            <a:solidFill>
-              <a:srgbClr val="1F2A30"/>
-            </a:solidFill>
-            <a:effectLst/>
-          </c:spPr>
-          <c:invertIfNegative val="0"/>
-          <c:dLbls>
-            <c:numFmt formatCode="0&quot;%&quot;" sourceLinked="0"/>
-            <c:txPr>
-              <a:bodyPr/>
-              <a:lstStyle/>
-              <a:p>
-                <a:pPr>
-                  <a:defRPr b="0" i="0" strike="noStrike" sz="1100" u="none">
-                    <a:solidFill>
-                      <a:srgbClr val="1F2A30"/>
-                    </a:solidFill>
-                    <a:latin typeface="Calibri"/>
-                  </a:defRPr>
-                </a:pPr>
-              </a:p>
-            </c:txPr>
-            <c:showLegendKey val="0"/>
-            <c:showVal val="1"/>
-            <c:showCatName val="0"/>
-            <c:showSerName val="0"/>
-            <c:showPercent val="0"/>
-            <c:showBubbleSize val="0"/>
-            <c:showLeaderLines val="0"/>
-          </c:dLbls>
-          <c:dPt>
-            <c:idx val="0"/>
-            <c:invertIfNegative val="0"/>
-            <c:bubble3D val="0"/>
-            <c:spPr>
-              <a:solidFill>
-                <a:srgbClr val="1F2A30"/>
-              </a:solidFill>
-              <a:effectLst/>
-            </c:spPr>
-          </c:dPt>
-          <c:dPt>
-            <c:idx val="1"/>
-            <c:invertIfNegative val="0"/>
-            <c:bubble3D val="0"/>
-            <c:spPr>
-              <a:solidFill>
-                <a:srgbClr val="B8C2C8"/>
-              </a:solidFill>
-              <a:effectLst/>
-            </c:spPr>
-          </c:dPt>
-          <c:dPt>
-            <c:idx val="2"/>
-            <c:invertIfNegative val="0"/>
-            <c:bubble3D val="0"/>
-            <c:spPr>
-              <a:solidFill>
-                <a:srgbClr val="B8C2C8"/>
-              </a:solidFill>
-              <a:effectLst/>
-            </c:spPr>
-          </c:dPt>
-          <c:dPt>
-            <c:idx val="3"/>
-            <c:invertIfNegative val="0"/>
-            <c:bubble3D val="0"/>
-            <c:spPr>
-              <a:solidFill>
-                <a:srgbClr val="B8C2C8"/>
-              </a:solidFill>
-              <a:effectLst/>
-            </c:spPr>
-          </c:dPt>
-          <c:dPt>
-            <c:idx val="4"/>
-            <c:invertIfNegative val="0"/>
-            <c:bubble3D val="0"/>
-            <c:spPr>
-              <a:solidFill>
-                <a:srgbClr val="D98E04"/>
-              </a:solidFill>
-              <a:effectLst/>
-            </c:spPr>
-          </c:dPt>
-          <c:cat>
-            <c:multiLvlStrRef>
-              <c:f>Sheet1!$A$2:$A$6</c:f>
-              <c:multiLvlStrCache>
-                <c:ptCount val="5"/>
-                <c:lvl>
-                  <c:pt idx="0">
-                    <c:v>All questions</c:v>
-                  </c:pt>
-                  <c:pt idx="1">
-                    <c:v>Constrained</c:v>
-                  </c:pt>
-                  <c:pt idx="2">
-                    <c:v>Basic</c:v>
-                  </c:pt>
-                  <c:pt idx="3">
-                    <c:v>Intra-doc reasoning</c:v>
-                  </c:pt>
-                  <c:pt idx="4">
-                    <c:v>Semantic</c:v>
-                  </c:pt>
-                </c:lvl>
-              </c:multiLvlStrCache>
-            </c:multiLvlStrRef>
-          </c:cat>
-          <c:val>
-            <c:numRef>
-              <c:f>Sheet1!$B$2:$B$6</c:f>
-              <c:numCache>
-                <c:formatCode>General</c:formatCode>
-                <c:ptCount val="5"/>
-                <c:pt idx="0">
-                  <c:v>84.4</c:v>
-                </c:pt>
-                <c:pt idx="1">
-                  <c:v>100</c:v>
-                </c:pt>
-                <c:pt idx="2">
-                  <c:v>91.4</c:v>
-                </c:pt>
-                <c:pt idx="3">
-                  <c:v>86.7</c:v>
-                </c:pt>
-                <c:pt idx="4">
-                  <c:v>64</c:v>
-                </c:pt>
-              </c:numCache>
-            </c:numRef>
-          </c:val>
-        </c:ser>
-        <c:dLbls>
-          <c:numFmt formatCode="0&quot;%&quot;" sourceLinked="0"/>
-          <c:txPr>
-            <a:bodyPr/>
-            <a:lstStyle/>
-            <a:p>
-              <a:pPr>
-                <a:defRPr b="0" i="0" strike="noStrike" sz="1100" u="none">
-                  <a:solidFill>
-                    <a:srgbClr val="1F2A30"/>
-                  </a:solidFill>
-                  <a:latin typeface="Calibri"/>
-                </a:defRPr>
-              </a:pPr>
-            </a:p>
-          </c:txPr>
-          <c:showLegendKey val="0"/>
-          <c:showVal val="1"/>
-          <c:showCatName val="0"/>
-          <c:showSerName val="0"/>
-          <c:showPercent val="0"/>
-          <c:showBubbleSize val="0"/>
-          <c:showLeaderLines val="0"/>
-        </c:dLbls>
-        <c:gapWidth val="45"/>
-        <c:overlap val="0"/>
-        <c:axId val="2094734554"/>
-        <c:axId val="2094734552"/>
-        <c:axId val="2094734556"/>
-      </c:barChart>
-      <c:catAx>
-        <c:axId val="2094734554"/>
-        <c:scaling>
-          <c:orientation val="maxMin"/>
-        </c:scaling>
-        <c:delete val="0"/>
-        <c:axPos val="l"/>
-        <c:numFmt formatCode="General" sourceLinked="1"/>
-        <c:majorTickMark val="out"/>
-        <c:minorTickMark val="none"/>
-        <c:tickLblPos val="nextTo"/>
-        <c:spPr>
-          <a:ln w="12700" cap="flat">
-            <a:noFill/>
-            <a:prstDash val="solid"/>
-            <a:round/>
-          </a:ln>
-        </c:spPr>
-        <c:txPr>
-          <a:bodyPr/>
-          <a:lstStyle/>
-          <a:p>
-            <a:pPr>
-              <a:defRPr sz="1100" b="0" i="0" u="none" strike="noStrike">
-                <a:solidFill>
-                  <a:srgbClr val="1F2A30"/>
-                </a:solidFill>
-                <a:latin typeface="Calibri"/>
-              </a:defRPr>
-            </a:pPr>
-            <a:endParaRPr lang="en-US"/>
-          </a:p>
-        </c:txPr>
-        <c:crossAx val="2094734552"/>
-        <c:crosses val="autoZero"/>
-        <c:auto val="1"/>
-        <c:lblAlgn val="ctr"/>
-        <c:noMultiLvlLbl val="1"/>
-      </c:catAx>
-      <c:valAx>
-        <c:axId val="2094734552"/>
-        <c:scaling>
-          <c:orientation val="minMax"/>
-          <c:max val="115"/>
-          <c:min val="0"/>
-        </c:scaling>
-        <c:delete val="1"/>
-        <c:axPos val="b"/>
-        <c:numFmt formatCode="General" sourceLinked="0"/>
-        <c:majorTickMark val="out"/>
-        <c:minorTickMark val="none"/>
-        <c:tickLblPos val="low"/>
-        <c:spPr>
-          <a:ln w="12700" cap="flat">
-            <a:solidFill>
-              <a:srgbClr val="888888"/>
-            </a:solidFill>
-            <a:prstDash val="solid"/>
-            <a:round/>
-          </a:ln>
-        </c:spPr>
-        <c:txPr>
-          <a:bodyPr/>
-          <a:lstStyle/>
-          <a:p>
-            <a:pPr>
-              <a:defRPr sz="1200" b="0" i="0" u="none" strike="noStrike">
-                <a:solidFill>
-                  <a:srgbClr val="000000"/>
-                </a:solidFill>
-                <a:latin typeface="Arial"/>
-              </a:defRPr>
-            </a:pPr>
-            <a:endParaRPr lang="en-US"/>
-          </a:p>
-        </c:txPr>
-        <c:crossAx val="2094734554"/>
-        <c:crosses val="autoZero"/>
-        <c:crossBetween val="between"/>
-      </c:valAx>
-      <c:spPr>
-        <a:noFill/>
-        <a:ln>
-          <a:noFill/>
-        </a:ln>
-        <a:effectLst/>
-      </c:spPr>
-    </c:plotArea>
-    <c:plotVisOnly val="1"/>
-    <c:dispBlanksAs val="span"/>
-  </c:chart>
-  <c:spPr>
-    <a:noFill/>
-    <a:ln>
-      <a:noFill/>
-    </a:ln>
-    <a:effectLst/>
-  </c:spPr>
-  <c:externalData r:id="rId1">
-    <c:autoUpdate val="0"/>
-  </c:externalData>
-</c:chartSpace>
 </file>
 
 <file path=ppt/notesMasters/notesMaster1.xml><?xml version="1.0" encoding="utf-8"?>
@@ -830,8 +505,8 @@
               <a:rPr lang="en-US" dirty="0"/>
               <a:t>Speaking target: 55 seconds.
 Support teams want fast, correct answers from company documents, but running the full retrieval pipeline on every question is slow and costly, and answering from weak evidence is risky.
-Our idea is to match retrieval effort to the question. First, check a cache of verified answers: a repeat question reuses its answer. Otherwise, retrieve and rerank evidence. Then check that evidence. If it is weak, search once more, at most once. Finally, answer with citations, or refuse if the evidence is still insufficient.
-Today the retrieval step is built: a local MiniLM search over company documents. The other steps are planned.
+Our idea is to match retrieval effort to the question. First, check a cache of verified answers: a repeat question reuses its answer. Otherwise, retrieve evidence with hybrid search, combining vector and keyword search. Then check that evidence: if the two searches disagree, search once more, at most once. Finally, answer with citations, or refuse if the evidence is still insufficient.
+Today steps 2 and 3 are built and measured on retrieval. The cache and the answering step are planned.
 Prior work such as Adaptive-RAG routes by question complexity, and Self-RAG learns when to retrieve and critiques itself. Both decide when to retrieve. We decide how much effort an enterprise question deserves, including reusing an answer or refusing, and we measure the quality-versus-cost tradeoff. Cost savings are still a hypothesis.
 Sources:
 Jeong et al., Adaptive-RAG, NAACL 2024: https://aclanthology.org/2024.naacl-long.389/
@@ -924,20 +599,19 @@
             <a:r>
               <a:rPr lang="en-US" dirty="0"/>
               <a:t>Speaking target: 65 seconds, then about one minute of questions.
-We built a reproducible retrieval baseline on a subset of EnterpriseRAG-Bench: 100 questions and 290 documents, split into 3,358 passages and indexed with MiniLM. For 84 percent of the 90 answerable questions, the correct document is in the top five. MRR is 0.67. Constrained and basic questions do well, but semantic questions, the paraphrased ones, drop to 64 percent. A rerun reproduced every rank exactly.
-Our main takeaway: finding the right document is not the same as finding the answer. In one example the correct email thread ranked first, but its best passage starts just after the five-business-day detail the question asks for. So retrieval scores alone overstate readiness, and we need to check evidence before answering.
-Before the final report: hybrid keyword plus MiniLM search with a reranker for the semantic gap; grounded answers with citations and refusal; the evidence check, verified cache, and one retry; then a plot of answer quality against latency and cost. We will also grow to about 300 questions, including multi-document ones.
-Results: https://github.com/AdithNG/adaptive-enterprise-retrieval/blob/midterm-presentation/results/midterm/retrieval_eval_20261019-023503/summary.json
-Dataset: https://github.com/onyx-dot-app/EnterpriseRAG-Bench
+We tested this idea on our development set of 62 answerable questions. Ranking quality here is nDCG at 5, where 1 means the correct document is ranked first.
+Plain vector search scores 0.807. Adding keyword search to make it hybrid raises that to 0.846, at the same 30 milliseconds. Next we tried an extra search step, where a small local LLM rewrites the query using the first results. Doing that on every question is slow, about 1.3 seconds, and it actually ranks slightly worse, 0.825.
+So we made it adaptive: we run the extra search only when keyword search and vector search disagree on the top document. That happens on 46 percent of questions. The result is the best ranking, 0.855, at 592 milliseconds, less than half the latency of always searching. That is our main takeaway: spending effort only where the question needs it can be both cheaper and better.
+These are development results with a stronger embedding model, Qwen3, so next we confirm them on validation and test questions. Then we add grounded answers with citations and refusal, a verified cache for repeat questions, and end-to-end measures of answer quality, latency and cost, and we grow to about 300 questions, including multi-document ones.
+Source: Ty's optimization experiments, branch feat-retrieval-optimizations, experiments/optimizations (figure 4, combinations-dev-20261020-01: 8 passes, 3,312 requests).
 Q&amp;A:
-What is Hit@5? The share of answerable questions with a correct document among the top five ranked documents.
-What is MRR? The average of 1/rank of the first correct document. It is not the average rank.
-Why 290 documents? 90 gold documents plus 200 related documents chosen as hard negatives. Full-corpus performance is not established.
-Have you reduced cost? Not yet. This run measures retrieval only; adaptive comparisons come next.
-Do you evaluate refusal? Not yet. Ten unanswerable questions are logged but excluded from retrieval scores.
-Held-out results? Test Hit@5 is 12/15, a small split. Treat it as descriptive; no tuning was done.
-Multi-document questions? None in the current subset; we plan to add them.
-Failure example: qst_0187 (harmful-output warnings over two evaluation windows): the correct document ranks sixth, behind general incident guidance.</a:t>
+What is nDCG@5? A score for the top-5 ranking: 1 if the correct document is first, lower the further down it appears, 0 if it is missing.
+Recall@5? Hybrid 0.919; extra search always 0.935; only when needed 0.935. The gain is mostly in ranking order, not in finding new documents.
+Why not a reranker? We tried the ms-marco MiniLM cross-encoder. It lowered nDCG@5 from 0.807 to 0.781, likely because it was trained on web search, not enterprise documents.
+What is the extra search? LameR: an LLM (Llama 3.2 3B, run locally) drafts likely answers from the top keyword results, and we search again with them.
+Is the gain significant? Paired bootstrap intervals were computed; the run is small (62 questions) and on the development split only, so we present it as an observation.
+Why is this different from the earlier MiniLM numbers? These runs use Qwen3-Embedding-0.6B and a separate experiment harness, so the numbers are not directly comparable.
+Is this cost or only latency? Latency only, on an M4 Max laptop with warm models. Hardware and energy cost are not measured; there are no paid API calls.</a:t>
             </a:r>
             <a:endParaRPr lang="en-US" dirty="0"/>
           </a:p>
@@ -1694,7 +1368,7 @@
                 <a:ea typeface="Calibri" pitchFamily="34" charset="-122"/>
                 <a:cs typeface="Calibri" pitchFamily="34" charset="-120"/>
               </a:rPr>
-              <a:t>Retrieve + rerank</a:t>
+              <a:t>Hybrid retrieval</a:t>
             </a:r>
             <a:endParaRPr lang="en-US" sz="1400" dirty="0"/>
           </a:p>
@@ -1733,7 +1407,7 @@
                 <a:ea typeface="Calibri" pitchFamily="34" charset="-122"/>
                 <a:cs typeface="Calibri" pitchFamily="34" charset="-120"/>
               </a:rPr>
-              <a:t>MiniLM search built today</a:t>
+              <a:t>Vector + keyword search</a:t>
             </a:r>
             <a:endParaRPr lang="en-US" sz="1100" dirty="0"/>
           </a:p>
@@ -1780,13 +1454,13 @@
             </a:avLst>
           </a:prstGeom>
           <a:solidFill>
-            <a:srgbClr val="FFFFFF"/>
+            <a:srgbClr val="0F7C80"/>
           </a:solidFill>
           <a:ln w="15875">
             <a:solidFill>
-              <a:srgbClr val="B8C2C8"/>
+              <a:srgbClr val="0F7C80"/>
             </a:solidFill>
-            <a:prstDash val="dash"/>
+            <a:prstDash val="solid"/>
           </a:ln>
         </p:spPr>
       </p:sp>
@@ -1817,7 +1491,7 @@
             <a:r>
               <a:rPr lang="en-US" sz="1400" b="1" dirty="0">
                 <a:solidFill>
-                  <a:srgbClr val="0F7C80"/>
+                  <a:srgbClr val="FFFFFF"/>
                 </a:solidFill>
                 <a:latin typeface="Calibri" pitchFamily="34" charset="0"/>
                 <a:ea typeface="Calibri" pitchFamily="34" charset="-122"/>
@@ -1856,7 +1530,7 @@
             <a:r>
               <a:rPr lang="en-US" sz="1400" b="1" dirty="0">
                 <a:solidFill>
-                  <a:srgbClr val="1F2A30"/>
+                  <a:srgbClr val="FFFFFF"/>
                 </a:solidFill>
                 <a:latin typeface="Calibri" pitchFamily="34" charset="0"/>
                 <a:ea typeface="Calibri" pitchFamily="34" charset="-122"/>
@@ -1895,13 +1569,13 @@
             <a:r>
               <a:rPr lang="en-US" sz="1100" dirty="0">
                 <a:solidFill>
-                  <a:srgbClr val="5B6770"/>
-                </a:solidFill>
-                <a:latin typeface="Calibri" pitchFamily="34" charset="0"/>
-                <a:ea typeface="Calibri" pitchFamily="34" charset="-122"/>
-                <a:cs typeface="Calibri" pitchFamily="34" charset="-120"/>
-              </a:rPr>
-              <a:t>Weak? Search once more</a:t>
+                  <a:srgbClr val="FFFFFF"/>
+                </a:solidFill>
+                <a:latin typeface="Calibri" pitchFamily="34" charset="0"/>
+                <a:ea typeface="Calibri" pitchFamily="34" charset="-122"/>
+                <a:cs typeface="Calibri" pitchFamily="34" charset="-120"/>
+              </a:rPr>
+              <a:t>Disagree? Search again</a:t>
             </a:r>
             <a:endParaRPr lang="en-US" sz="1100" dirty="0"/>
           </a:p>
@@ -2555,7 +2229,7 @@
                 <a:ea typeface="Calibri" pitchFamily="34" charset="-122"/>
                 <a:cs typeface="Calibri" pitchFamily="34" charset="-120"/>
               </a:rPr>
-              <a:t>The right document is not always the answer</a:t>
+              <a:t>Search harder only when it is needed</a:t>
             </a:r>
             <a:endParaRPr lang="en-US" sz="2800" dirty="0"/>
           </a:p>
@@ -2594,42 +2268,645 @@
                 <a:ea typeface="Calibri" pitchFamily="34" charset="-122"/>
                 <a:cs typeface="Calibri" pitchFamily="34" charset="-120"/>
               </a:rPr>
-              <a:t>MiniLM baseline on an EnterpriseRAG-Bench subset: 100 questions, 290 documents, 3,358 passages</a:t>
+              <a:t>Extra LLM-assisted search runs only when keyword and vector search disagree on the top document</a:t>
             </a:r>
             <a:endParaRPr lang="en-US" sz="1400" dirty="0"/>
           </a:p>
         </p:txBody>
       </p:sp>
-      <p:graphicFrame>
-        <p:nvGraphicFramePr>
-          <p:cNvPr id="5" name="hit5-by-type" descr=""/>
-          <p:cNvGraphicFramePr/>
-          <p:nvPr/>
-        </p:nvGraphicFramePr>
-        <p:xfrm>
-          <a:off x="365760" y="1417320"/>
-          <a:ext cx="4297680" cy="1965960"/>
-        </p:xfrm>
-        <a:graphic xmlns:a="http://schemas.openxmlformats.org/drawingml/2006/main">
-          <a:graphicData uri="http://schemas.openxmlformats.org/drawingml/2006/chart">
-            <c:chart xmlns:c="http://schemas.openxmlformats.org/drawingml/2006/chart" r:id="rId1"/>
-          </a:graphicData>
-        </a:graphic>
-      </p:graphicFrame>
-      <p:sp>
-        <p:nvSpPr>
-          <p:cNvPr id="6" name="example"/>
+      <p:sp>
+        <p:nvSpPr>
+          <p:cNvPr id="5" name="Text 3"/>
+          <p:cNvSpPr txBox="1"/>
+          <p:nvPr/>
+        </p:nvSpPr>
+        <p:spPr>
+          <a:xfrm>
+            <a:off x="2743200" y="1481328"/>
+            <a:ext cx="868680" cy="228600"/>
+          </a:xfrm>
+          <a:prstGeom prst="rect">
+            <a:avLst/>
+          </a:prstGeom>
+          <a:noFill/>
+          <a:ln/>
+        </p:spPr>
+        <p:txBody>
+          <a:bodyPr wrap="square" lIns="0" tIns="0" rIns="0" bIns="0" rtlCol="0" anchor="t"/>
+          <a:lstStyle/>
+          <a:p>
+            <a:pPr algn="r" indent="0" marL="0">
+              <a:buNone/>
+            </a:pPr>
+            <a:r>
+              <a:rPr lang="en-US" sz="1000" b="1" dirty="0">
+                <a:solidFill>
+                  <a:srgbClr val="5B6770"/>
+                </a:solidFill>
+                <a:latin typeface="Calibri" pitchFamily="34" charset="0"/>
+                <a:ea typeface="Calibri" pitchFamily="34" charset="-122"/>
+                <a:cs typeface="Calibri" pitchFamily="34" charset="-120"/>
+              </a:rPr>
+              <a:t>Ranking quality</a:t>
+            </a:r>
+            <a:endParaRPr lang="en-US" sz="1000" dirty="0"/>
+          </a:p>
+        </p:txBody>
+      </p:sp>
+      <p:sp>
+        <p:nvSpPr>
+          <p:cNvPr id="6" name="Text 4"/>
+          <p:cNvSpPr txBox="1"/>
+          <p:nvPr/>
+        </p:nvSpPr>
+        <p:spPr>
+          <a:xfrm>
+            <a:off x="3886200" y="1481328"/>
+            <a:ext cx="822960" cy="228600"/>
+          </a:xfrm>
+          <a:prstGeom prst="rect">
+            <a:avLst/>
+          </a:prstGeom>
+          <a:noFill/>
+          <a:ln/>
+        </p:spPr>
+        <p:txBody>
+          <a:bodyPr wrap="square" lIns="0" tIns="0" rIns="0" bIns="0" rtlCol="0" anchor="t"/>
+          <a:lstStyle/>
+          <a:p>
+            <a:pPr algn="r" indent="0" marL="0">
+              <a:buNone/>
+            </a:pPr>
+            <a:r>
+              <a:rPr lang="en-US" sz="1000" b="1" dirty="0">
+                <a:solidFill>
+                  <a:srgbClr val="5B6770"/>
+                </a:solidFill>
+                <a:latin typeface="Calibri" pitchFamily="34" charset="0"/>
+                <a:ea typeface="Calibri" pitchFamily="34" charset="-122"/>
+                <a:cs typeface="Calibri" pitchFamily="34" charset="-120"/>
+              </a:rPr>
+              <a:t>Latency</a:t>
+            </a:r>
+            <a:endParaRPr lang="en-US" sz="1000" dirty="0"/>
+          </a:p>
+        </p:txBody>
+      </p:sp>
+      <p:sp>
+        <p:nvSpPr>
+          <p:cNvPr id="7" name="Text 5"/>
+          <p:cNvSpPr txBox="1"/>
+          <p:nvPr/>
+        </p:nvSpPr>
+        <p:spPr>
+          <a:xfrm>
+            <a:off x="502920" y="1819656"/>
+            <a:ext cx="2468880" cy="274320"/>
+          </a:xfrm>
+          <a:prstGeom prst="rect">
+            <a:avLst/>
+          </a:prstGeom>
+          <a:noFill/>
+          <a:ln/>
+        </p:spPr>
+        <p:txBody>
+          <a:bodyPr wrap="square" lIns="0" tIns="0" rIns="0" bIns="0" rtlCol="0" anchor="t"/>
+          <a:lstStyle/>
+          <a:p>
+            <a:pPr indent="0" marL="0">
+              <a:buNone/>
+            </a:pPr>
+            <a:r>
+              <a:rPr lang="en-US" sz="1400" dirty="0">
+                <a:solidFill>
+                  <a:srgbClr val="1F2A30"/>
+                </a:solidFill>
+                <a:latin typeface="Calibri" pitchFamily="34" charset="0"/>
+                <a:ea typeface="Calibri" pitchFamily="34" charset="-122"/>
+                <a:cs typeface="Calibri" pitchFamily="34" charset="-120"/>
+              </a:rPr>
+              <a:t>Vector search only</a:t>
+            </a:r>
+            <a:endParaRPr lang="en-US" sz="1400" dirty="0"/>
+          </a:p>
+        </p:txBody>
+      </p:sp>
+      <p:sp>
+        <p:nvSpPr>
+          <p:cNvPr id="8" name="Text 6"/>
+          <p:cNvSpPr txBox="1"/>
+          <p:nvPr/>
+        </p:nvSpPr>
+        <p:spPr>
+          <a:xfrm>
+            <a:off x="3063240" y="1819656"/>
+            <a:ext cx="548640" cy="274320"/>
+          </a:xfrm>
+          <a:prstGeom prst="rect">
+            <a:avLst/>
+          </a:prstGeom>
+          <a:noFill/>
+          <a:ln/>
+        </p:spPr>
+        <p:txBody>
+          <a:bodyPr wrap="square" lIns="0" tIns="0" rIns="0" bIns="0" rtlCol="0" anchor="t"/>
+          <a:lstStyle/>
+          <a:p>
+            <a:pPr algn="r" indent="0" marL="0">
+              <a:buNone/>
+            </a:pPr>
+            <a:r>
+              <a:rPr lang="en-US" sz="1400" dirty="0">
+                <a:solidFill>
+                  <a:srgbClr val="1F2A30"/>
+                </a:solidFill>
+                <a:latin typeface="Calibri" pitchFamily="34" charset="0"/>
+                <a:ea typeface="Calibri" pitchFamily="34" charset="-122"/>
+                <a:cs typeface="Calibri" pitchFamily="34" charset="-120"/>
+              </a:rPr>
+              <a:t>0.807</a:t>
+            </a:r>
+            <a:endParaRPr lang="en-US" sz="1400" dirty="0"/>
+          </a:p>
+        </p:txBody>
+      </p:sp>
+      <p:sp>
+        <p:nvSpPr>
+          <p:cNvPr id="9" name="Text 7"/>
+          <p:cNvSpPr txBox="1"/>
+          <p:nvPr/>
+        </p:nvSpPr>
+        <p:spPr>
+          <a:xfrm>
+            <a:off x="3886200" y="1819656"/>
+            <a:ext cx="822960" cy="274320"/>
+          </a:xfrm>
+          <a:prstGeom prst="rect">
+            <a:avLst/>
+          </a:prstGeom>
+          <a:noFill/>
+          <a:ln/>
+        </p:spPr>
+        <p:txBody>
+          <a:bodyPr wrap="square" lIns="0" tIns="0" rIns="0" bIns="0" rtlCol="0" anchor="t"/>
+          <a:lstStyle/>
+          <a:p>
+            <a:pPr algn="r" indent="0" marL="0">
+              <a:buNone/>
+            </a:pPr>
+            <a:r>
+              <a:rPr lang="en-US" sz="1400" dirty="0">
+                <a:solidFill>
+                  <a:srgbClr val="1F2A30"/>
+                </a:solidFill>
+                <a:latin typeface="Calibri" pitchFamily="34" charset="0"/>
+                <a:ea typeface="Calibri" pitchFamily="34" charset="-122"/>
+                <a:cs typeface="Calibri" pitchFamily="34" charset="-120"/>
+              </a:rPr>
+              <a:t>30 ms</a:t>
+            </a:r>
+            <a:endParaRPr lang="en-US" sz="1400" dirty="0"/>
+          </a:p>
+        </p:txBody>
+      </p:sp>
+      <p:sp>
+        <p:nvSpPr>
+          <p:cNvPr id="10" name="Shape 8"/>
           <p:cNvSpPr/>
           <p:nvPr/>
         </p:nvSpPr>
         <p:spPr>
           <a:xfrm>
-            <a:off x="457200" y="3520440"/>
-            <a:ext cx="4160520" cy="1051560"/>
+            <a:off x="457200" y="2167128"/>
+            <a:ext cx="4251960" cy="0"/>
+          </a:xfrm>
+          <a:prstGeom prst="line">
+            <a:avLst/>
+          </a:prstGeom>
+          <a:noFill/>
+          <a:ln w="12700">
+            <a:solidFill>
+              <a:srgbClr val="F1F3F4"/>
+            </a:solidFill>
+            <a:prstDash val="solid"/>
+          </a:ln>
+        </p:spPr>
+      </p:sp>
+      <p:sp>
+        <p:nvSpPr>
+          <p:cNvPr id="11" name="Text 9"/>
+          <p:cNvSpPr txBox="1"/>
+          <p:nvPr/>
+        </p:nvSpPr>
+        <p:spPr>
+          <a:xfrm>
+            <a:off x="502920" y="2258568"/>
+            <a:ext cx="2468880" cy="274320"/>
+          </a:xfrm>
+          <a:prstGeom prst="rect">
+            <a:avLst/>
+          </a:prstGeom>
+          <a:noFill/>
+          <a:ln/>
+        </p:spPr>
+        <p:txBody>
+          <a:bodyPr wrap="square" lIns="0" tIns="0" rIns="0" bIns="0" rtlCol="0" anchor="t"/>
+          <a:lstStyle/>
+          <a:p>
+            <a:pPr indent="0" marL="0">
+              <a:buNone/>
+            </a:pPr>
+            <a:r>
+              <a:rPr lang="en-US" sz="1400" dirty="0">
+                <a:solidFill>
+                  <a:srgbClr val="1F2A30"/>
+                </a:solidFill>
+                <a:latin typeface="Calibri" pitchFamily="34" charset="0"/>
+                <a:ea typeface="Calibri" pitchFamily="34" charset="-122"/>
+                <a:cs typeface="Calibri" pitchFamily="34" charset="-120"/>
+              </a:rPr>
+              <a:t>Hybrid: vector + keyword</a:t>
+            </a:r>
+            <a:endParaRPr lang="en-US" sz="1400" dirty="0"/>
+          </a:p>
+        </p:txBody>
+      </p:sp>
+      <p:sp>
+        <p:nvSpPr>
+          <p:cNvPr id="12" name="Text 10"/>
+          <p:cNvSpPr txBox="1"/>
+          <p:nvPr/>
+        </p:nvSpPr>
+        <p:spPr>
+          <a:xfrm>
+            <a:off x="3063240" y="2258568"/>
+            <a:ext cx="548640" cy="274320"/>
+          </a:xfrm>
+          <a:prstGeom prst="rect">
+            <a:avLst/>
+          </a:prstGeom>
+          <a:noFill/>
+          <a:ln/>
+        </p:spPr>
+        <p:txBody>
+          <a:bodyPr wrap="square" lIns="0" tIns="0" rIns="0" bIns="0" rtlCol="0" anchor="t"/>
+          <a:lstStyle/>
+          <a:p>
+            <a:pPr algn="r" indent="0" marL="0">
+              <a:buNone/>
+            </a:pPr>
+            <a:r>
+              <a:rPr lang="en-US" sz="1400" dirty="0">
+                <a:solidFill>
+                  <a:srgbClr val="1F2A30"/>
+                </a:solidFill>
+                <a:latin typeface="Calibri" pitchFamily="34" charset="0"/>
+                <a:ea typeface="Calibri" pitchFamily="34" charset="-122"/>
+                <a:cs typeface="Calibri" pitchFamily="34" charset="-120"/>
+              </a:rPr>
+              <a:t>0.846</a:t>
+            </a:r>
+            <a:endParaRPr lang="en-US" sz="1400" dirty="0"/>
+          </a:p>
+        </p:txBody>
+      </p:sp>
+      <p:sp>
+        <p:nvSpPr>
+          <p:cNvPr id="13" name="Text 11"/>
+          <p:cNvSpPr txBox="1"/>
+          <p:nvPr/>
+        </p:nvSpPr>
+        <p:spPr>
+          <a:xfrm>
+            <a:off x="3886200" y="2258568"/>
+            <a:ext cx="822960" cy="274320"/>
+          </a:xfrm>
+          <a:prstGeom prst="rect">
+            <a:avLst/>
+          </a:prstGeom>
+          <a:noFill/>
+          <a:ln/>
+        </p:spPr>
+        <p:txBody>
+          <a:bodyPr wrap="square" lIns="0" tIns="0" rIns="0" bIns="0" rtlCol="0" anchor="t"/>
+          <a:lstStyle/>
+          <a:p>
+            <a:pPr algn="r" indent="0" marL="0">
+              <a:buNone/>
+            </a:pPr>
+            <a:r>
+              <a:rPr lang="en-US" sz="1400" dirty="0">
+                <a:solidFill>
+                  <a:srgbClr val="1F2A30"/>
+                </a:solidFill>
+                <a:latin typeface="Calibri" pitchFamily="34" charset="0"/>
+                <a:ea typeface="Calibri" pitchFamily="34" charset="-122"/>
+                <a:cs typeface="Calibri" pitchFamily="34" charset="-120"/>
+              </a:rPr>
+              <a:t>30 ms</a:t>
+            </a:r>
+            <a:endParaRPr lang="en-US" sz="1400" dirty="0"/>
+          </a:p>
+        </p:txBody>
+      </p:sp>
+      <p:sp>
+        <p:nvSpPr>
+          <p:cNvPr id="14" name="Shape 12"/>
+          <p:cNvSpPr/>
+          <p:nvPr/>
+        </p:nvSpPr>
+        <p:spPr>
+          <a:xfrm>
+            <a:off x="457200" y="2606040"/>
+            <a:ext cx="4251960" cy="0"/>
+          </a:xfrm>
+          <a:prstGeom prst="line">
+            <a:avLst/>
+          </a:prstGeom>
+          <a:noFill/>
+          <a:ln w="12700">
+            <a:solidFill>
+              <a:srgbClr val="F1F3F4"/>
+            </a:solidFill>
+            <a:prstDash val="solid"/>
+          </a:ln>
+        </p:spPr>
+      </p:sp>
+      <p:sp>
+        <p:nvSpPr>
+          <p:cNvPr id="15" name="Text 13"/>
+          <p:cNvSpPr txBox="1"/>
+          <p:nvPr/>
+        </p:nvSpPr>
+        <p:spPr>
+          <a:xfrm>
+            <a:off x="502920" y="2697480"/>
+            <a:ext cx="2468880" cy="274320"/>
+          </a:xfrm>
+          <a:prstGeom prst="rect">
+            <a:avLst/>
+          </a:prstGeom>
+          <a:noFill/>
+          <a:ln/>
+        </p:spPr>
+        <p:txBody>
+          <a:bodyPr wrap="square" lIns="0" tIns="0" rIns="0" bIns="0" rtlCol="0" anchor="t"/>
+          <a:lstStyle/>
+          <a:p>
+            <a:pPr indent="0" marL="0">
+              <a:buNone/>
+            </a:pPr>
+            <a:r>
+              <a:rPr lang="en-US" sz="1400" dirty="0">
+                <a:solidFill>
+                  <a:srgbClr val="1F2A30"/>
+                </a:solidFill>
+                <a:latin typeface="Calibri" pitchFamily="34" charset="0"/>
+                <a:ea typeface="Calibri" pitchFamily="34" charset="-122"/>
+                <a:cs typeface="Calibri" pitchFamily="34" charset="-120"/>
+              </a:rPr>
+              <a:t>+ extra search, every question</a:t>
+            </a:r>
+            <a:endParaRPr lang="en-US" sz="1400" dirty="0"/>
+          </a:p>
+        </p:txBody>
+      </p:sp>
+      <p:sp>
+        <p:nvSpPr>
+          <p:cNvPr id="16" name="Text 14"/>
+          <p:cNvSpPr txBox="1"/>
+          <p:nvPr/>
+        </p:nvSpPr>
+        <p:spPr>
+          <a:xfrm>
+            <a:off x="3063240" y="2697480"/>
+            <a:ext cx="548640" cy="274320"/>
+          </a:xfrm>
+          <a:prstGeom prst="rect">
+            <a:avLst/>
+          </a:prstGeom>
+          <a:noFill/>
+          <a:ln/>
+        </p:spPr>
+        <p:txBody>
+          <a:bodyPr wrap="square" lIns="0" tIns="0" rIns="0" bIns="0" rtlCol="0" anchor="t"/>
+          <a:lstStyle/>
+          <a:p>
+            <a:pPr algn="r" indent="0" marL="0">
+              <a:buNone/>
+            </a:pPr>
+            <a:r>
+              <a:rPr lang="en-US" sz="1400" dirty="0">
+                <a:solidFill>
+                  <a:srgbClr val="1F2A30"/>
+                </a:solidFill>
+                <a:latin typeface="Calibri" pitchFamily="34" charset="0"/>
+                <a:ea typeface="Calibri" pitchFamily="34" charset="-122"/>
+                <a:cs typeface="Calibri" pitchFamily="34" charset="-120"/>
+              </a:rPr>
+              <a:t>0.825</a:t>
+            </a:r>
+            <a:endParaRPr lang="en-US" sz="1400" dirty="0"/>
+          </a:p>
+        </p:txBody>
+      </p:sp>
+      <p:sp>
+        <p:nvSpPr>
+          <p:cNvPr id="17" name="Text 15"/>
+          <p:cNvSpPr txBox="1"/>
+          <p:nvPr/>
+        </p:nvSpPr>
+        <p:spPr>
+          <a:xfrm>
+            <a:off x="3886200" y="2697480"/>
+            <a:ext cx="822960" cy="274320"/>
+          </a:xfrm>
+          <a:prstGeom prst="rect">
+            <a:avLst/>
+          </a:prstGeom>
+          <a:noFill/>
+          <a:ln/>
+        </p:spPr>
+        <p:txBody>
+          <a:bodyPr wrap="square" lIns="0" tIns="0" rIns="0" bIns="0" rtlCol="0" anchor="t"/>
+          <a:lstStyle/>
+          <a:p>
+            <a:pPr algn="r" indent="0" marL="0">
+              <a:buNone/>
+            </a:pPr>
+            <a:r>
+              <a:rPr lang="en-US" sz="1400" dirty="0">
+                <a:solidFill>
+                  <a:srgbClr val="1F2A30"/>
+                </a:solidFill>
+                <a:latin typeface="Calibri" pitchFamily="34" charset="0"/>
+                <a:ea typeface="Calibri" pitchFamily="34" charset="-122"/>
+                <a:cs typeface="Calibri" pitchFamily="34" charset="-120"/>
+              </a:rPr>
+              <a:t>1,320 ms</a:t>
+            </a:r>
+            <a:endParaRPr lang="en-US" sz="1400" dirty="0"/>
+          </a:p>
+        </p:txBody>
+      </p:sp>
+      <p:sp>
+        <p:nvSpPr>
+          <p:cNvPr id="18" name="best-row"/>
+          <p:cNvSpPr/>
+          <p:nvPr/>
+        </p:nvSpPr>
+        <p:spPr>
+          <a:xfrm>
+            <a:off x="365760" y="3044952"/>
+            <a:ext cx="4434840" cy="438912"/>
           </a:xfrm>
           <a:prstGeom prst="roundRect">
             <a:avLst>
-              <a:gd name="adj" fmla="val 6957"/>
+              <a:gd name="adj" fmla="val 12500"/>
+            </a:avLst>
+          </a:prstGeom>
+          <a:solidFill>
+            <a:srgbClr val="E3F1F1"/>
+          </a:solidFill>
+          <a:ln w="12700">
+            <a:solidFill>
+              <a:srgbClr val="E3F1F1"/>
+            </a:solidFill>
+            <a:prstDash val="solid"/>
+          </a:ln>
+        </p:spPr>
+      </p:sp>
+      <p:sp>
+        <p:nvSpPr>
+          <p:cNvPr id="19" name="Text 17"/>
+          <p:cNvSpPr txBox="1"/>
+          <p:nvPr/>
+        </p:nvSpPr>
+        <p:spPr>
+          <a:xfrm>
+            <a:off x="502920" y="3136392"/>
+            <a:ext cx="2468880" cy="274320"/>
+          </a:xfrm>
+          <a:prstGeom prst="rect">
+            <a:avLst/>
+          </a:prstGeom>
+          <a:noFill/>
+          <a:ln/>
+        </p:spPr>
+        <p:txBody>
+          <a:bodyPr wrap="square" lIns="0" tIns="0" rIns="0" bIns="0" rtlCol="0" anchor="t"/>
+          <a:lstStyle/>
+          <a:p>
+            <a:pPr indent="0" marL="0">
+              <a:buNone/>
+            </a:pPr>
+            <a:r>
+              <a:rPr lang="en-US" sz="1400" b="1" dirty="0">
+                <a:solidFill>
+                  <a:srgbClr val="0F7C80"/>
+                </a:solidFill>
+                <a:latin typeface="Calibri" pitchFamily="34" charset="0"/>
+                <a:ea typeface="Calibri" pitchFamily="34" charset="-122"/>
+                <a:cs typeface="Calibri" pitchFamily="34" charset="-120"/>
+              </a:rPr>
+              <a:t>+ extra search, when needed</a:t>
+            </a:r>
+            <a:endParaRPr lang="en-US" sz="1400" dirty="0"/>
+          </a:p>
+        </p:txBody>
+      </p:sp>
+      <p:sp>
+        <p:nvSpPr>
+          <p:cNvPr id="20" name="Text 18"/>
+          <p:cNvSpPr txBox="1"/>
+          <p:nvPr/>
+        </p:nvSpPr>
+        <p:spPr>
+          <a:xfrm>
+            <a:off x="3063240" y="3136392"/>
+            <a:ext cx="548640" cy="274320"/>
+          </a:xfrm>
+          <a:prstGeom prst="rect">
+            <a:avLst/>
+          </a:prstGeom>
+          <a:noFill/>
+          <a:ln/>
+        </p:spPr>
+        <p:txBody>
+          <a:bodyPr wrap="square" lIns="0" tIns="0" rIns="0" bIns="0" rtlCol="0" anchor="t"/>
+          <a:lstStyle/>
+          <a:p>
+            <a:pPr algn="r" indent="0" marL="0">
+              <a:buNone/>
+            </a:pPr>
+            <a:r>
+              <a:rPr lang="en-US" sz="1400" b="1" dirty="0">
+                <a:solidFill>
+                  <a:srgbClr val="0F7C80"/>
+                </a:solidFill>
+                <a:latin typeface="Calibri" pitchFamily="34" charset="0"/>
+                <a:ea typeface="Calibri" pitchFamily="34" charset="-122"/>
+                <a:cs typeface="Calibri" pitchFamily="34" charset="-120"/>
+              </a:rPr>
+              <a:t>0.855</a:t>
+            </a:r>
+            <a:endParaRPr lang="en-US" sz="1400" dirty="0"/>
+          </a:p>
+        </p:txBody>
+      </p:sp>
+      <p:sp>
+        <p:nvSpPr>
+          <p:cNvPr id="21" name="Text 19"/>
+          <p:cNvSpPr txBox="1"/>
+          <p:nvPr/>
+        </p:nvSpPr>
+        <p:spPr>
+          <a:xfrm>
+            <a:off x="3886200" y="3136392"/>
+            <a:ext cx="822960" cy="274320"/>
+          </a:xfrm>
+          <a:prstGeom prst="rect">
+            <a:avLst/>
+          </a:prstGeom>
+          <a:noFill/>
+          <a:ln/>
+        </p:spPr>
+        <p:txBody>
+          <a:bodyPr wrap="square" lIns="0" tIns="0" rIns="0" bIns="0" rtlCol="0" anchor="t"/>
+          <a:lstStyle/>
+          <a:p>
+            <a:pPr algn="r" indent="0" marL="0">
+              <a:buNone/>
+            </a:pPr>
+            <a:r>
+              <a:rPr lang="en-US" sz="1400" b="1" dirty="0">
+                <a:solidFill>
+                  <a:srgbClr val="0F7C80"/>
+                </a:solidFill>
+                <a:latin typeface="Calibri" pitchFamily="34" charset="0"/>
+                <a:ea typeface="Calibri" pitchFamily="34" charset="-122"/>
+                <a:cs typeface="Calibri" pitchFamily="34" charset="-120"/>
+              </a:rPr>
+              <a:t>592 ms</a:t>
+            </a:r>
+            <a:endParaRPr lang="en-US" sz="1400" dirty="0"/>
+          </a:p>
+        </p:txBody>
+      </p:sp>
+      <p:sp>
+        <p:nvSpPr>
+          <p:cNvPr id="22" name="takeaway"/>
+          <p:cNvSpPr/>
+          <p:nvPr/>
+        </p:nvSpPr>
+        <p:spPr>
+          <a:xfrm>
+            <a:off x="457200" y="3657600"/>
+            <a:ext cx="4251960" cy="914400"/>
+          </a:xfrm>
+          <a:prstGeom prst="roundRect">
+            <a:avLst>
+              <a:gd name="adj" fmla="val 8000"/>
             </a:avLst>
           </a:prstGeom>
           <a:solidFill>
@@ -2645,14 +2922,14 @@
       </p:sp>
       <p:sp>
         <p:nvSpPr>
-          <p:cNvPr id="7" name="Text 4"/>
-          <p:cNvSpPr txBox="1"/>
-          <p:nvPr/>
-        </p:nvSpPr>
-        <p:spPr>
-          <a:xfrm>
-            <a:off x="640080" y="3657600"/>
-            <a:ext cx="3794760" cy="822960"/>
+          <p:cNvPr id="23" name="Text 21"/>
+          <p:cNvSpPr txBox="1"/>
+          <p:nvPr/>
+        </p:nvSpPr>
+        <p:spPr>
+          <a:xfrm>
+            <a:off x="640080" y="3794760"/>
+            <a:ext cx="3886200" cy="685800"/>
           </a:xfrm>
           <a:prstGeom prst="rect">
             <a:avLst/>
@@ -2676,7 +2953,7 @@
                 <a:ea typeface="Calibri" pitchFamily="34" charset="-122"/>
                 <a:cs typeface="Calibri" pitchFamily="34" charset="-120"/>
               </a:rPr>
-              <a:t>Example: </a:t>
+              <a:t>Takeaway: </a:t>
             </a:r>
             <a:pPr indent="0" marL="0">
               <a:buNone/>
@@ -2690,7 +2967,7 @@
                 <a:ea typeface="Calibri" pitchFamily="34" charset="-122"/>
                 <a:cs typeface="Calibri" pitchFamily="34" charset="-120"/>
               </a:rPr>
-              <a:t>the correct email thread ranked #1, but its best passage starts just after the answer (a five-day runbook turnaround). A document hit is not yet usable evidence.</a:t>
+              <a:t>targeting the extra search (46% of questions) cuts latency by more than half versus always searching, and ranks better.</a:t>
             </a:r>
             <a:endParaRPr lang="en-US" sz="1300" dirty="0"/>
           </a:p>
@@ -2698,14 +2975,14 @@
       </p:sp>
       <p:sp>
         <p:nvSpPr>
-          <p:cNvPr id="8" name="Text 5"/>
-          <p:cNvSpPr txBox="1"/>
-          <p:nvPr/>
-        </p:nvSpPr>
-        <p:spPr>
-          <a:xfrm>
-            <a:off x="4983480" y="1463040"/>
-            <a:ext cx="3657600" cy="228600"/>
+          <p:cNvPr id="24" name="Text 22"/>
+          <p:cNvSpPr txBox="1"/>
+          <p:nvPr/>
+        </p:nvSpPr>
+        <p:spPr>
+          <a:xfrm>
+            <a:off x="5120640" y="1481328"/>
+            <a:ext cx="3566160" cy="228600"/>
           </a:xfrm>
           <a:prstGeom prst="rect">
             <a:avLst/>
@@ -2737,13 +3014,13 @@
       </p:sp>
       <p:sp>
         <p:nvSpPr>
-          <p:cNvPr id="9" name="Text 6"/>
-          <p:cNvSpPr txBox="1"/>
-          <p:nvPr/>
-        </p:nvSpPr>
-        <p:spPr>
-          <a:xfrm>
-            <a:off x="4983480" y="1828800"/>
+          <p:cNvPr id="25" name="Text 23"/>
+          <p:cNvSpPr txBox="1"/>
+          <p:nvPr/>
+        </p:nvSpPr>
+        <p:spPr>
+          <a:xfrm>
+            <a:off x="5120640" y="1828800"/>
             <a:ext cx="274320" cy="365760"/>
           </a:xfrm>
           <a:prstGeom prst="rect">
@@ -2776,14 +3053,14 @@
       </p:sp>
       <p:sp>
         <p:nvSpPr>
-          <p:cNvPr id="10" name="Text 7"/>
-          <p:cNvSpPr txBox="1"/>
-          <p:nvPr/>
-        </p:nvSpPr>
-        <p:spPr>
-          <a:xfrm>
-            <a:off x="5303520" y="1828800"/>
-            <a:ext cx="3429000" cy="365760"/>
+          <p:cNvPr id="26" name="Text 24"/>
+          <p:cNvSpPr txBox="1"/>
+          <p:nvPr/>
+        </p:nvSpPr>
+        <p:spPr>
+          <a:xfrm>
+            <a:off x="5413248" y="1828800"/>
+            <a:ext cx="3291840" cy="365760"/>
           </a:xfrm>
           <a:prstGeom prst="rect">
             <a:avLst/>
@@ -2807,7 +3084,7 @@
                 <a:ea typeface="Calibri" pitchFamily="34" charset="-122"/>
                 <a:cs typeface="Calibri" pitchFamily="34" charset="-120"/>
               </a:rPr>
-              <a:t>Keyword + MiniLM search with a reranker</a:t>
+              <a:t>Confirm on validation and test questions</a:t>
             </a:r>
             <a:endParaRPr lang="en-US" sz="1400" dirty="0"/>
           </a:p>
@@ -2815,13 +3092,13 @@
       </p:sp>
       <p:sp>
         <p:nvSpPr>
-          <p:cNvPr id="11" name="Text 8"/>
-          <p:cNvSpPr txBox="1"/>
-          <p:nvPr/>
-        </p:nvSpPr>
-        <p:spPr>
-          <a:xfrm>
-            <a:off x="4983480" y="2304288"/>
+          <p:cNvPr id="27" name="Text 25"/>
+          <p:cNvSpPr txBox="1"/>
+          <p:nvPr/>
+        </p:nvSpPr>
+        <p:spPr>
+          <a:xfrm>
+            <a:off x="5120640" y="2304288"/>
             <a:ext cx="274320" cy="365760"/>
           </a:xfrm>
           <a:prstGeom prst="rect">
@@ -2854,14 +3131,14 @@
       </p:sp>
       <p:sp>
         <p:nvSpPr>
-          <p:cNvPr id="12" name="Text 9"/>
-          <p:cNvSpPr txBox="1"/>
-          <p:nvPr/>
-        </p:nvSpPr>
-        <p:spPr>
-          <a:xfrm>
-            <a:off x="5303520" y="2304288"/>
-            <a:ext cx="3429000" cy="365760"/>
+          <p:cNvPr id="28" name="Text 26"/>
+          <p:cNvSpPr txBox="1"/>
+          <p:nvPr/>
+        </p:nvSpPr>
+        <p:spPr>
+          <a:xfrm>
+            <a:off x="5413248" y="2304288"/>
+            <a:ext cx="3291840" cy="365760"/>
           </a:xfrm>
           <a:prstGeom prst="rect">
             <a:avLst/>
@@ -2893,13 +3170,13 @@
       </p:sp>
       <p:sp>
         <p:nvSpPr>
-          <p:cNvPr id="13" name="Text 10"/>
-          <p:cNvSpPr txBox="1"/>
-          <p:nvPr/>
-        </p:nvSpPr>
-        <p:spPr>
-          <a:xfrm>
-            <a:off x="4983480" y="2779776"/>
+          <p:cNvPr id="29" name="Text 27"/>
+          <p:cNvSpPr txBox="1"/>
+          <p:nvPr/>
+        </p:nvSpPr>
+        <p:spPr>
+          <a:xfrm>
+            <a:off x="5120640" y="2779776"/>
             <a:ext cx="274320" cy="365760"/>
           </a:xfrm>
           <a:prstGeom prst="rect">
@@ -2932,14 +3209,14 @@
       </p:sp>
       <p:sp>
         <p:nvSpPr>
-          <p:cNvPr id="14" name="Text 11"/>
-          <p:cNvSpPr txBox="1"/>
-          <p:nvPr/>
-        </p:nvSpPr>
-        <p:spPr>
-          <a:xfrm>
-            <a:off x="5303520" y="2779776"/>
-            <a:ext cx="3429000" cy="365760"/>
+          <p:cNvPr id="30" name="Text 28"/>
+          <p:cNvSpPr txBox="1"/>
+          <p:nvPr/>
+        </p:nvSpPr>
+        <p:spPr>
+          <a:xfrm>
+            <a:off x="5413248" y="2779776"/>
+            <a:ext cx="3291840" cy="365760"/>
           </a:xfrm>
           <a:prstGeom prst="rect">
             <a:avLst/>
@@ -2963,7 +3240,7 @@
                 <a:ea typeface="Calibri" pitchFamily="34" charset="-122"/>
                 <a:cs typeface="Calibri" pitchFamily="34" charset="-120"/>
               </a:rPr>
-              <a:t>Evidence check, verified cache, and one retry</a:t>
+              <a:t>Verified cache for repeat questions</a:t>
             </a:r>
             <a:endParaRPr lang="en-US" sz="1400" dirty="0"/>
           </a:p>
@@ -2971,13 +3248,13 @@
       </p:sp>
       <p:sp>
         <p:nvSpPr>
-          <p:cNvPr id="15" name="Text 12"/>
-          <p:cNvSpPr txBox="1"/>
-          <p:nvPr/>
-        </p:nvSpPr>
-        <p:spPr>
-          <a:xfrm>
-            <a:off x="4983480" y="3255264"/>
+          <p:cNvPr id="31" name="Text 29"/>
+          <p:cNvSpPr txBox="1"/>
+          <p:nvPr/>
+        </p:nvSpPr>
+        <p:spPr>
+          <a:xfrm>
+            <a:off x="5120640" y="3255264"/>
             <a:ext cx="274320" cy="365760"/>
           </a:xfrm>
           <a:prstGeom prst="rect">
@@ -3010,14 +3287,14 @@
       </p:sp>
       <p:sp>
         <p:nvSpPr>
-          <p:cNvPr id="16" name="Text 13"/>
-          <p:cNvSpPr txBox="1"/>
-          <p:nvPr/>
-        </p:nvSpPr>
-        <p:spPr>
-          <a:xfrm>
-            <a:off x="5303520" y="3255264"/>
-            <a:ext cx="3429000" cy="365760"/>
+          <p:cNvPr id="32" name="Text 30"/>
+          <p:cNvSpPr txBox="1"/>
+          <p:nvPr/>
+        </p:nvSpPr>
+        <p:spPr>
+          <a:xfrm>
+            <a:off x="5413248" y="3255264"/>
+            <a:ext cx="3291840" cy="365760"/>
           </a:xfrm>
           <a:prstGeom prst="rect">
             <a:avLst/>
@@ -3041,7 +3318,7 @@
                 <a:ea typeface="Calibri" pitchFamily="34" charset="-122"/>
                 <a:cs typeface="Calibri" pitchFamily="34" charset="-120"/>
               </a:rPr>
-              <a:t>Plot answer quality against latency and cost</a:t>
+              <a:t>Measure answer quality, latency and cost</a:t>
             </a:r>
             <a:endParaRPr lang="en-US" sz="1400" dirty="0"/>
           </a:p>
@@ -3049,13 +3326,13 @@
       </p:sp>
       <p:sp>
         <p:nvSpPr>
-          <p:cNvPr id="17" name="Text 14"/>
-          <p:cNvSpPr txBox="1"/>
-          <p:nvPr/>
-        </p:nvSpPr>
-        <p:spPr>
-          <a:xfrm>
-            <a:off x="4983480" y="3730752"/>
+          <p:cNvPr id="33" name="Text 31"/>
+          <p:cNvSpPr txBox="1"/>
+          <p:nvPr/>
+        </p:nvSpPr>
+        <p:spPr>
+          <a:xfrm>
+            <a:off x="5120640" y="3730752"/>
             <a:ext cx="274320" cy="365760"/>
           </a:xfrm>
           <a:prstGeom prst="rect">
@@ -3088,14 +3365,14 @@
       </p:sp>
       <p:sp>
         <p:nvSpPr>
-          <p:cNvPr id="18" name="Text 15"/>
-          <p:cNvSpPr txBox="1"/>
-          <p:nvPr/>
-        </p:nvSpPr>
-        <p:spPr>
-          <a:xfrm>
-            <a:off x="5303520" y="3730752"/>
-            <a:ext cx="3429000" cy="365760"/>
+          <p:cNvPr id="34" name="Text 32"/>
+          <p:cNvSpPr txBox="1"/>
+          <p:nvPr/>
+        </p:nvSpPr>
+        <p:spPr>
+          <a:xfrm>
+            <a:off x="5413248" y="3730752"/>
+            <a:ext cx="3291840" cy="365760"/>
           </a:xfrm>
           <a:prstGeom prst="rect">
             <a:avLst/>
@@ -3119,7 +3396,7 @@
                 <a:ea typeface="Calibri" pitchFamily="34" charset="-122"/>
                 <a:cs typeface="Calibri" pitchFamily="34" charset="-120"/>
               </a:rPr>
-              <a:t>Grow to ~300 questions, incl. multi-document</a:t>
+              <a:t>Grow to ~300 questions, incl. multi-doc</a:t>
             </a:r>
             <a:endParaRPr lang="en-US" sz="1400" dirty="0"/>
           </a:p>
@@ -3127,14 +3404,14 @@
       </p:sp>
       <p:sp>
         <p:nvSpPr>
-          <p:cNvPr id="19" name="Text 16"/>
-          <p:cNvSpPr txBox="1"/>
-          <p:nvPr/>
-        </p:nvSpPr>
-        <p:spPr>
-          <a:xfrm>
-            <a:off x="457200" y="4727448"/>
-            <a:ext cx="8229600" cy="228600"/>
+          <p:cNvPr id="35" name="Text 33"/>
+          <p:cNvSpPr txBox="1"/>
+          <p:nvPr/>
+        </p:nvSpPr>
+        <p:spPr>
+          <a:xfrm>
+            <a:off x="457200" y="4681728"/>
+            <a:ext cx="8229600" cy="274320"/>
           </a:xfrm>
           <a:prstGeom prst="rect">
             <a:avLst/>
@@ -3158,7 +3435,7 @@
                 <a:ea typeface="Calibri" pitchFamily="34" charset="-122"/>
                 <a:cs typeface="Calibri" pitchFamily="34" charset="-120"/>
               </a:rPr>
-              <a:t>Exploratory: splits pooled; 90 answerable questions scored, 10 unanswerable excluded. Answer quality and cost savings are not measured yet.</a:t>
+              <a:t>Dev set: 62 answerable questions, Qwen3-Embedding-0.6B, M4 Max. Ranking quality = nDCG@5 (1 = perfect). Not yet validated on held-out data.</a:t>
             </a:r>
             <a:endParaRPr lang="en-US" sz="1000" dirty="0"/>
           </a:p>

</xml_diff>

<commit_message>
Add end-to-end RAG prototype results to midterm deck
Include John's feat-rag-metrics rehearsal: local Qwen3-4B cited answers or
refusal, with generation taking ~96% of per-question time. Slide 1 now marks
the answer step as built; next steps updated accordingly.

Co-Authored-By: Claude Opus 5.5 <noreply@anthropic.com>
</commit_message>
<xml_diff>
--- a/docs/presentation/Team13-Midterm-v2.pptx
+++ b/docs/presentation/Team13-Midterm-v2.pptx
@@ -506,7 +506,7 @@
               <a:t>Speaking target: 55 seconds.
 Support teams want fast, correct answers from company documents, but running the full retrieval pipeline on every question is slow and costly, and answering from weak evidence is risky.
 Our idea is to match retrieval effort to the question. First, check a cache of verified answers: a repeat question reuses its answer. Otherwise, retrieve evidence with hybrid search, combining vector and keyword search. Then check that evidence: if the two searches disagree, search once more, at most once. Finally, answer with citations, or refuse if the evidence is still insufficient.
-Today steps 2 and 3 are built and measured on retrieval. The cache and the answering step are planned.
+Today steps 2 to 4 are built as prototypes. The verified cache is planned.
 Prior work such as Adaptive-RAG routes by question complexity, and Self-RAG learns when to retrieve and critiques itself. Both decide when to retrieve. We decide how much effort an enterprise question deserves, including reusing an answer or refusing, and we measure the quality-versus-cost tradeoff. Cost savings are still a hypothesis.
 Sources:
 Jeong et al., Adaptive-RAG, NAACL 2024: https://aclanthology.org/2024.naacl-long.389/
@@ -602,8 +602,10 @@
 We tested this idea on our development set of 62 answerable questions. Ranking quality here is nDCG at 5, where 1 means the correct document is ranked first.
 Plain vector search scores 0.807. Adding keyword search to make it hybrid raises that to 0.846, at the same 30 milliseconds. Next we tried an extra search step, where a small local LLM rewrites the query using the first results. Doing that on every question is slow, about 1.3 seconds, and it actually ranks slightly worse, 0.825.
 So we made it adaptive: we run the extra search only when keyword search and vector search disagree on the top document. That happens on 46 percent of questions. The result is the best ranking, 0.855, at 592 milliseconds, less than half the latency of always searching. That is our main takeaway: spending effort only where the question needs it can be both cheaper and better.
-These are development results with a stronger embedding model, Qwen3, so next we confirm them on validation and test questions. Then we add grounded answers with citations and refusal, a verified cache for repeat questions, and end-to-end measures of answer quality, latency and cost, and we grow to about 300 questions, including multi-document ones.
-Source: Ty's optimization experiments, branch feat-retrieval-optimizations, experiments/optimizations (figure 4, combinations-dev-20261020-01: 8 passes, 3,312 requests).
+We also have an end-to-end prototype: a local Qwen3 4B model writes an answer with citations, or refuses when the passages do not support one. In our rehearsal questions, about 96 percent of each answer's time was the model writing it, three and a half to six seconds, versus well under a second for retrieval. So the biggest remaining saving is reusing verified answers, which is our next step.
+Before the final report we confirm these development results on validation and test questions, score answers and refusals on every question, add the verified cache, and grow to about 300 questions, including multi-document ones.
+Answering source: John's feat-rag-metrics branch, demoplan.md (offline rehearsal on an Apple M4 Pro: qst_0026 answered with two valid citations in 6.21 s, 6.05 s generation; the Gmail password question and qst_0046 refused in 3.96 s and 3.64 s).
+Retrieval source: Ty's optimization experiments, branch feat-retrieval-optimizations, experiments/optimizations (figure 4, combinations-dev-20261020-01: 8 passes, 3,312 requests).
 Q&amp;A:
 What is nDCG@5? A score for the top-5 ranking: 1 if the correct document is first, lower the further down it appears, 0 if it is missing.
 Recall@5? Hybrid 0.919; extra search always 0.935; only when needed 0.935. The gain is mostly in ranking order, not in finding new documents.
@@ -611,6 +613,7 @@
 What is the extra search? LameR: an LLM (Llama 3.2 3B, run locally) drafts likely answers from the top keyword results, and we search again with them.
 Is the gain significant? Paired bootstrap intervals were computed; the run is small (62 questions) and on the development split only, so we present it as an observation.
 Why is this different from the earlier MiniLM numbers? These runs use Qwen3-Embedding-0.6B and a separate experiment harness, so the numbers are not directly comparable.
+Does refusal work? A first check: the off-topic Gmail question was refused. qst_0046 was also refused because its retrieved passages missed the 5-business-day answer, a retrieval limit rather than a model error. Citations and quotes are checked by code; semantic correctness is not yet verified at scale.
 Is this cost or only latency? Latency only, on an M4 Max laptop with warm models. Hardware and energy cost are not measured; there are no paid API calls.</a:t>
             </a:r>
             <a:endParaRPr lang="en-US" dirty="0"/>
@@ -1622,13 +1625,13 @@
             </a:avLst>
           </a:prstGeom>
           <a:solidFill>
-            <a:srgbClr val="FFFFFF"/>
+            <a:srgbClr val="0F7C80"/>
           </a:solidFill>
           <a:ln w="15875">
             <a:solidFill>
-              <a:srgbClr val="B8C2C8"/>
+              <a:srgbClr val="0F7C80"/>
             </a:solidFill>
-            <a:prstDash val="dash"/>
+            <a:prstDash val="solid"/>
           </a:ln>
         </p:spPr>
       </p:sp>
@@ -1659,7 +1662,7 @@
             <a:r>
               <a:rPr lang="en-US" sz="1400" b="1" dirty="0">
                 <a:solidFill>
-                  <a:srgbClr val="0F7C80"/>
+                  <a:srgbClr val="FFFFFF"/>
                 </a:solidFill>
                 <a:latin typeface="Calibri" pitchFamily="34" charset="0"/>
                 <a:ea typeface="Calibri" pitchFamily="34" charset="-122"/>
@@ -1698,7 +1701,7 @@
             <a:r>
               <a:rPr lang="en-US" sz="1400" b="1" dirty="0">
                 <a:solidFill>
-                  <a:srgbClr val="1F2A30"/>
+                  <a:srgbClr val="FFFFFF"/>
                 </a:solidFill>
                 <a:latin typeface="Calibri" pitchFamily="34" charset="0"/>
                 <a:ea typeface="Calibri" pitchFamily="34" charset="-122"/>
@@ -1737,7 +1740,7 @@
             <a:r>
               <a:rPr lang="en-US" sz="1100" dirty="0">
                 <a:solidFill>
-                  <a:srgbClr val="5B6770"/>
+                  <a:srgbClr val="FFFFFF"/>
                 </a:solidFill>
                 <a:latin typeface="Calibri" pitchFamily="34" charset="0"/>
                 <a:ea typeface="Calibri" pitchFamily="34" charset="-122"/>
@@ -3006,6 +3009,112 @@
                 <a:ea typeface="Calibri" pitchFamily="34" charset="-122"/>
                 <a:cs typeface="Calibri" pitchFamily="34" charset="-120"/>
               </a:rPr>
+              <a:t>END-TO-END PROTOTYPE</a:t>
+            </a:r>
+            <a:endParaRPr lang="en-US" sz="1100" dirty="0"/>
+          </a:p>
+        </p:txBody>
+      </p:sp>
+      <p:sp>
+        <p:nvSpPr>
+          <p:cNvPr id="25" name="Text 23"/>
+          <p:cNvSpPr txBox="1"/>
+          <p:nvPr/>
+        </p:nvSpPr>
+        <p:spPr>
+          <a:xfrm>
+            <a:off x="5120640" y="1783080"/>
+            <a:ext cx="3611880" cy="914400"/>
+          </a:xfrm>
+          <a:prstGeom prst="rect">
+            <a:avLst/>
+          </a:prstGeom>
+          <a:noFill/>
+          <a:ln/>
+        </p:spPr>
+        <p:txBody>
+          <a:bodyPr wrap="square" lIns="0" tIns="0" rIns="0" bIns="0" rtlCol="0" anchor="t"/>
+          <a:lstStyle/>
+          <a:p>
+            <a:pPr indent="0" marL="0">
+              <a:buNone/>
+            </a:pPr>
+            <a:r>
+              <a:rPr lang="en-US" sz="1300" dirty="0">
+                <a:solidFill>
+                  <a:srgbClr val="1F2A30"/>
+                </a:solidFill>
+                <a:latin typeface="Calibri" pitchFamily="34" charset="0"/>
+                <a:ea typeface="Calibri" pitchFamily="34" charset="-122"/>
+                <a:cs typeface="Calibri" pitchFamily="34" charset="-120"/>
+              </a:rPr>
+              <a:t>A local Qwen3-4B writes cited answers or refuses. Each answer takes up to 6 s, and </a:t>
+            </a:r>
+            <a:pPr indent="0" marL="0">
+              <a:buNone/>
+            </a:pPr>
+            <a:r>
+              <a:rPr lang="en-US" sz="1300" b="1" dirty="0">
+                <a:solidFill>
+                  <a:srgbClr val="1F2A30"/>
+                </a:solidFill>
+                <a:latin typeface="Calibri" pitchFamily="34" charset="0"/>
+                <a:ea typeface="Calibri" pitchFamily="34" charset="-122"/>
+                <a:cs typeface="Calibri" pitchFamily="34" charset="-120"/>
+              </a:rPr>
+              <a:t>~96% of that is the LLM writing</a:t>
+            </a:r>
+            <a:pPr indent="0" marL="0">
+              <a:buNone/>
+            </a:pPr>
+            <a:r>
+              <a:rPr lang="en-US" sz="1300" dirty="0">
+                <a:solidFill>
+                  <a:srgbClr val="1F2A30"/>
+                </a:solidFill>
+                <a:latin typeface="Calibri" pitchFamily="34" charset="0"/>
+                <a:ea typeface="Calibri" pitchFamily="34" charset="-122"/>
+                <a:cs typeface="Calibri" pitchFamily="34" charset="-120"/>
+              </a:rPr>
+              <a:t>, so reusing verified answers saves the most.</a:t>
+            </a:r>
+            <a:endParaRPr lang="en-US" sz="1300" dirty="0"/>
+          </a:p>
+        </p:txBody>
+      </p:sp>
+      <p:sp>
+        <p:nvSpPr>
+          <p:cNvPr id="26" name="Text 24"/>
+          <p:cNvSpPr txBox="1"/>
+          <p:nvPr/>
+        </p:nvSpPr>
+        <p:spPr>
+          <a:xfrm>
+            <a:off x="5120640" y="2852928"/>
+            <a:ext cx="3566160" cy="228600"/>
+          </a:xfrm>
+          <a:prstGeom prst="rect">
+            <a:avLst/>
+          </a:prstGeom>
+          <a:noFill/>
+          <a:ln/>
+        </p:spPr>
+        <p:txBody>
+          <a:bodyPr wrap="square" lIns="0" tIns="0" rIns="0" bIns="0" rtlCol="0" anchor="t"/>
+          <a:lstStyle/>
+          <a:p>
+            <a:pPr indent="0" marL="0">
+              <a:buNone/>
+            </a:pPr>
+            <a:r>
+              <a:rPr lang="en-US" sz="1100" b="1" spc="100" kern="0" dirty="0">
+                <a:solidFill>
+                  <a:srgbClr val="0F7C80"/>
+                </a:solidFill>
+                <a:latin typeface="Calibri" pitchFamily="34" charset="0"/>
+                <a:ea typeface="Calibri" pitchFamily="34" charset="-122"/>
+                <a:cs typeface="Calibri" pitchFamily="34" charset="-120"/>
+              </a:rPr>
               <a:t>BEFORE THE FINAL REPORT</a:t>
             </a:r>
             <a:endParaRPr lang="en-US" sz="1100" dirty="0"/>
@@ -3014,14 +3123,14 @@
       </p:sp>
       <p:sp>
         <p:nvSpPr>
-          <p:cNvPr id="25" name="Text 23"/>
-          <p:cNvSpPr txBox="1"/>
-          <p:nvPr/>
-        </p:nvSpPr>
-        <p:spPr>
-          <a:xfrm>
-            <a:off x="5120640" y="1828800"/>
-            <a:ext cx="274320" cy="365760"/>
+          <p:cNvPr id="27" name="Text 25"/>
+          <p:cNvSpPr txBox="1"/>
+          <p:nvPr/>
+        </p:nvSpPr>
+        <p:spPr>
+          <a:xfrm>
+            <a:off x="5120640" y="3154680"/>
+            <a:ext cx="274320" cy="320040"/>
           </a:xfrm>
           <a:prstGeom prst="rect">
             <a:avLst/>
@@ -3053,14 +3162,14 @@
       </p:sp>
       <p:sp>
         <p:nvSpPr>
-          <p:cNvPr id="26" name="Text 24"/>
-          <p:cNvSpPr txBox="1"/>
-          <p:nvPr/>
-        </p:nvSpPr>
-        <p:spPr>
-          <a:xfrm>
-            <a:off x="5413248" y="1828800"/>
-            <a:ext cx="3291840" cy="365760"/>
+          <p:cNvPr id="28" name="Text 26"/>
+          <p:cNvSpPr txBox="1"/>
+          <p:nvPr/>
+        </p:nvSpPr>
+        <p:spPr>
+          <a:xfrm>
+            <a:off x="5413248" y="3154680"/>
+            <a:ext cx="3337560" cy="320040"/>
           </a:xfrm>
           <a:prstGeom prst="rect">
             <a:avLst/>
@@ -3092,14 +3201,14 @@
       </p:sp>
       <p:sp>
         <p:nvSpPr>
-          <p:cNvPr id="27" name="Text 25"/>
-          <p:cNvSpPr txBox="1"/>
-          <p:nvPr/>
-        </p:nvSpPr>
-        <p:spPr>
-          <a:xfrm>
-            <a:off x="5120640" y="2304288"/>
-            <a:ext cx="274320" cy="365760"/>
+          <p:cNvPr id="29" name="Text 27"/>
+          <p:cNvSpPr txBox="1"/>
+          <p:nvPr/>
+        </p:nvSpPr>
+        <p:spPr>
+          <a:xfrm>
+            <a:off x="5120640" y="3520440"/>
+            <a:ext cx="274320" cy="320040"/>
           </a:xfrm>
           <a:prstGeom prst="rect">
             <a:avLst/>
@@ -3131,14 +3240,14 @@
       </p:sp>
       <p:sp>
         <p:nvSpPr>
-          <p:cNvPr id="28" name="Text 26"/>
-          <p:cNvSpPr txBox="1"/>
-          <p:nvPr/>
-        </p:nvSpPr>
-        <p:spPr>
-          <a:xfrm>
-            <a:off x="5413248" y="2304288"/>
-            <a:ext cx="3291840" cy="365760"/>
+          <p:cNvPr id="30" name="Text 28"/>
+          <p:cNvSpPr txBox="1"/>
+          <p:nvPr/>
+        </p:nvSpPr>
+        <p:spPr>
+          <a:xfrm>
+            <a:off x="5413248" y="3520440"/>
+            <a:ext cx="3337560" cy="320040"/>
           </a:xfrm>
           <a:prstGeom prst="rect">
             <a:avLst/>
@@ -3162,7 +3271,7 @@
                 <a:ea typeface="Calibri" pitchFamily="34" charset="-122"/>
                 <a:cs typeface="Calibri" pitchFamily="34" charset="-120"/>
               </a:rPr>
-              <a:t>Grounded answers with citations, plus refusal</a:t>
+              <a:t>Score answers and refusals on all questions</a:t>
             </a:r>
             <a:endParaRPr lang="en-US" sz="1400" dirty="0"/>
           </a:p>
@@ -3170,14 +3279,14 @@
       </p:sp>
       <p:sp>
         <p:nvSpPr>
-          <p:cNvPr id="29" name="Text 27"/>
-          <p:cNvSpPr txBox="1"/>
-          <p:nvPr/>
-        </p:nvSpPr>
-        <p:spPr>
-          <a:xfrm>
-            <a:off x="5120640" y="2779776"/>
-            <a:ext cx="274320" cy="365760"/>
+          <p:cNvPr id="31" name="Text 29"/>
+          <p:cNvSpPr txBox="1"/>
+          <p:nvPr/>
+        </p:nvSpPr>
+        <p:spPr>
+          <a:xfrm>
+            <a:off x="5120640" y="3886200"/>
+            <a:ext cx="274320" cy="320040"/>
           </a:xfrm>
           <a:prstGeom prst="rect">
             <a:avLst/>
@@ -3209,14 +3318,14 @@
       </p:sp>
       <p:sp>
         <p:nvSpPr>
-          <p:cNvPr id="30" name="Text 28"/>
-          <p:cNvSpPr txBox="1"/>
-          <p:nvPr/>
-        </p:nvSpPr>
-        <p:spPr>
-          <a:xfrm>
-            <a:off x="5413248" y="2779776"/>
-            <a:ext cx="3291840" cy="365760"/>
+          <p:cNvPr id="32" name="Text 30"/>
+          <p:cNvSpPr txBox="1"/>
+          <p:nvPr/>
+        </p:nvSpPr>
+        <p:spPr>
+          <a:xfrm>
+            <a:off x="5413248" y="3886200"/>
+            <a:ext cx="3337560" cy="320040"/>
           </a:xfrm>
           <a:prstGeom prst="rect">
             <a:avLst/>
@@ -3248,14 +3357,14 @@
       </p:sp>
       <p:sp>
         <p:nvSpPr>
-          <p:cNvPr id="31" name="Text 29"/>
-          <p:cNvSpPr txBox="1"/>
-          <p:nvPr/>
-        </p:nvSpPr>
-        <p:spPr>
-          <a:xfrm>
-            <a:off x="5120640" y="3255264"/>
-            <a:ext cx="274320" cy="365760"/>
+          <p:cNvPr id="33" name="Text 31"/>
+          <p:cNvSpPr txBox="1"/>
+          <p:nvPr/>
+        </p:nvSpPr>
+        <p:spPr>
+          <a:xfrm>
+            <a:off x="5120640" y="4251960"/>
+            <a:ext cx="274320" cy="320040"/>
           </a:xfrm>
           <a:prstGeom prst="rect">
             <a:avLst/>
@@ -3287,92 +3396,14 @@
       </p:sp>
       <p:sp>
         <p:nvSpPr>
-          <p:cNvPr id="32" name="Text 30"/>
-          <p:cNvSpPr txBox="1"/>
-          <p:nvPr/>
-        </p:nvSpPr>
-        <p:spPr>
-          <a:xfrm>
-            <a:off x="5413248" y="3255264"/>
-            <a:ext cx="3291840" cy="365760"/>
-          </a:xfrm>
-          <a:prstGeom prst="rect">
-            <a:avLst/>
-          </a:prstGeom>
-          <a:noFill/>
-          <a:ln/>
-        </p:spPr>
-        <p:txBody>
-          <a:bodyPr wrap="square" lIns="0" tIns="0" rIns="0" bIns="0" rtlCol="0" anchor="t"/>
-          <a:lstStyle/>
-          <a:p>
-            <a:pPr indent="0" marL="0">
-              <a:buNone/>
-            </a:pPr>
-            <a:r>
-              <a:rPr lang="en-US" sz="1400" dirty="0">
-                <a:solidFill>
-                  <a:srgbClr val="1F2A30"/>
-                </a:solidFill>
-                <a:latin typeface="Calibri" pitchFamily="34" charset="0"/>
-                <a:ea typeface="Calibri" pitchFamily="34" charset="-122"/>
-                <a:cs typeface="Calibri" pitchFamily="34" charset="-120"/>
-              </a:rPr>
-              <a:t>Measure answer quality, latency and cost</a:t>
-            </a:r>
-            <a:endParaRPr lang="en-US" sz="1400" dirty="0"/>
-          </a:p>
-        </p:txBody>
-      </p:sp>
-      <p:sp>
-        <p:nvSpPr>
-          <p:cNvPr id="33" name="Text 31"/>
-          <p:cNvSpPr txBox="1"/>
-          <p:nvPr/>
-        </p:nvSpPr>
-        <p:spPr>
-          <a:xfrm>
-            <a:off x="5120640" y="3730752"/>
-            <a:ext cx="274320" cy="365760"/>
-          </a:xfrm>
-          <a:prstGeom prst="rect">
-            <a:avLst/>
-          </a:prstGeom>
-          <a:noFill/>
-          <a:ln/>
-        </p:spPr>
-        <p:txBody>
-          <a:bodyPr wrap="square" lIns="0" tIns="0" rIns="0" bIns="0" rtlCol="0" anchor="t"/>
-          <a:lstStyle/>
-          <a:p>
-            <a:pPr indent="0" marL="0">
-              <a:buNone/>
-            </a:pPr>
-            <a:r>
-              <a:rPr lang="en-US" sz="1400" b="1" dirty="0">
-                <a:solidFill>
-                  <a:srgbClr val="0F7C80"/>
-                </a:solidFill>
-                <a:latin typeface="Calibri" pitchFamily="34" charset="0"/>
-                <a:ea typeface="Calibri" pitchFamily="34" charset="-122"/>
-                <a:cs typeface="Calibri" pitchFamily="34" charset="-120"/>
-              </a:rPr>
-              <a:t>5</a:t>
-            </a:r>
-            <a:endParaRPr lang="en-US" sz="1400" dirty="0"/>
-          </a:p>
-        </p:txBody>
-      </p:sp>
-      <p:sp>
-        <p:nvSpPr>
           <p:cNvPr id="34" name="Text 32"/>
           <p:cNvSpPr txBox="1"/>
           <p:nvPr/>
         </p:nvSpPr>
         <p:spPr>
           <a:xfrm>
-            <a:off x="5413248" y="3730752"/>
-            <a:ext cx="3291840" cy="365760"/>
+            <a:off x="5413248" y="4251960"/>
+            <a:ext cx="3337560" cy="320040"/>
           </a:xfrm>
           <a:prstGeom prst="rect">
             <a:avLst/>
@@ -3435,7 +3466,7 @@
                 <a:ea typeface="Calibri" pitchFamily="34" charset="-122"/>
                 <a:cs typeface="Calibri" pitchFamily="34" charset="-120"/>
               </a:rPr>
-              <a:t>Dev set: 62 answerable questions, Qwen3-Embedding-0.6B, M4 Max. Ranking quality = nDCG@5 (1 = perfect). Not yet validated on held-out data.</a:t>
+              <a:t>Retrieval: 62 dev questions, Qwen3-Embedding-0.6B, nDCG@5 (1 = perfect). Answering: 3 rehearsal questions. Not yet validated on held-out data.</a:t>
             </a:r>
             <a:endParaRPr lang="en-US" sz="1000" dirty="0"/>
           </a:p>

</xml_diff>